<commit_message>
Publish final submission materials and verified Gemini evidence
</commit_message>
<xml_diff>
--- a/docs/Workflow-Rescue-Official-Pitch.pptx
+++ b/docs/Workflow-Rescue-Official-Pitch.pptx
@@ -955,7 +955,7 @@
           <a:lstStyle/>
           <a:p>
             <a:r>
-              <a:t>Local deterministic rehearsal; no Gemini calls in this image. This is a capture of the application's computed verification results. The provider and scenario must match its audit record. Never relabel rehearsal evidence as Gemini evidence.</a:t>
+              <a:t>Actual Gemini 3.5 Flash-Lite: custom incident, 4 model calls, 46.4 seconds including pacing; audit saved in Firestore. This is a capture of the application's computed verification results. The provider and scenario must match its audit record. Never relabel rehearsal evidence as Gemini evidence.</a:t>
             </a:r>
           </a:p>
         </p:txBody>
@@ -2023,7 +2023,7 @@
           <a:lstStyle/>
           <a:p>
             <a:r>
-              <a:t>Google deployment roles: Firebase Hosting for a static submission portal and prototype entry link; Cloud Run is planned for the FastAPI runtime; Firestore for durable audit documents; Gemini API for reasoning. Status badges reflect only confirmed deployment evidence. The static submission portal does not keep the Cloud Shell backend alive. A Firestore database write/read probe passed, but application-runtime persistence is pending until its credentials and save/load path have been verified. Do not call the in-memory simulator a durable distributed transaction engine. {"firebase_verified": false, "firestore_verified": false, "cloudrun_verified": false}</a:t>
+              <a:t>Google deployment roles: Firebase Hosting for a static submission portal and prototype entry link; Cloud Run is planned for the FastAPI runtime; Firestore for durable audit documents; Gemini API for reasoning. Status badges reflect only confirmed deployment evidence. The static submission portal does not keep the Cloud Shell backend alive. The application-runtime Firestore save/load integration has been verified. Do not call the in-memory simulator a durable distributed transaction engine. {"firebase_verified": true, "firestore_verified": true, "cloudrun_verified": false}</a:t>
             </a:r>
           </a:p>
         </p:txBody>
@@ -7040,7 +7040,7 @@
               </a:defRPr>
             </a:pPr>
             <a:r>
-              <a:t>Team leader name: [Registered team leader name]</a:t>
+              <a:t>Team leader name: TBC</a:t>
             </a:r>
           </a:p>
         </p:txBody>
@@ -7080,6 +7080,45 @@
             </a:pPr>
             <a:r>
               <a:t>Problem Statement: Recover interrupted enterprise workflows while preserving customer intent, permissions and a verifiable outcome.</a:t>
+            </a:r>
+          </a:p>
+        </p:txBody>
+      </p:sp>
+      <p:sp>
+        <p:nvSpPr>
+          <p:cNvPr id="62" name="TextBox 61"/>
+          <p:cNvSpPr txBox="1"/>
+          <p:nvPr/>
+        </p:nvSpPr>
+        <p:spPr>
+          <a:xfrm>
+            <a:off x="411480" y="4828032"/>
+            <a:ext cx="8183879" cy="201168"/>
+          </a:xfrm>
+          <a:prstGeom prst="rect">
+            <a:avLst/>
+          </a:prstGeom>
+          <a:noFill/>
+        </p:spPr>
+        <p:txBody>
+          <a:bodyPr wrap="square" lIns="0" rIns="0" tIns="0" bIns="0">
+            <a:spAutoFit/>
+          </a:bodyPr>
+          <a:lstStyle/>
+          <a:p>
+            <a:pPr algn="l">
+              <a:spcAft>
+                <a:spcPts val="300"/>
+              </a:spcAft>
+              <a:defRPr sz="950" b="0">
+                <a:solidFill>
+                  <a:srgbClr val="53637C"/>
+                </a:solidFill>
+                <a:latin typeface="Aptos"/>
+              </a:defRPr>
+            </a:pPr>
+            <a:r>
+              <a:t>Theme: Future of Work &amp; Enterprise Productivity</a:t>
             </a:r>
           </a:p>
         </p:txBody>
@@ -8075,7 +8114,7 @@
               </a:defRPr>
             </a:pPr>
             <a:r>
-              <a:t>The interface exposes the underlying record; a green animation alone is never proof.</a:t>
+              <a:t>Fresh custom input → live Gemini recovery → six independent checks → saved audit.</a:t>
             </a:r>
           </a:p>
         </p:txBody>
@@ -8129,7 +8168,7 @@
       </p:sp>
       <p:pic>
         <p:nvPicPr>
-          <p:cNvPr id="138" name="Picture 137" descr="rehearsal-checks-detail.png"/>
+          <p:cNvPr id="138" name="Picture 137" descr="custom-gemini-verification.png"/>
           <p:cNvPicPr>
             <a:picLocks noChangeAspect="1"/>
           </p:cNvPicPr>
@@ -8143,8 +8182,8 @@
         </p:blipFill>
         <p:spPr>
           <a:xfrm>
-            <a:off x="466344" y="1870030"/>
-            <a:ext cx="8174736" cy="2368131"/>
+            <a:off x="1597175" y="1810512"/>
+            <a:ext cx="5913072" cy="2487168"/>
           </a:xfrm>
           <a:prstGeom prst="rect">
             <a:avLst/>
@@ -8185,7 +8224,7 @@
               </a:defRPr>
             </a:pPr>
             <a:r>
-              <a:t>Local deterministic rehearsal; no Gemini calls in this image.</a:t>
+              <a:t>Actual Gemini 3.5 Flash-Lite: custom incident, 4 model calls, 46.4 seconds including pacing; audit saved in Firestore.</a:t>
             </a:r>
           </a:p>
         </p:txBody>
@@ -8555,7 +8594,7 @@
               </a:defRPr>
             </a:pPr>
             <a:r>
-              <a:t>82 Python tests</a:t>
+              <a:t>83 Python tests</a:t>
             </a:r>
           </a:p>
         </p:txBody>
@@ -10443,7 +10482,7 @@
               </a:defRPr>
             </a:pPr>
             <a:r>
-              <a:t>Persistent, publicly accessible hosting.</a:t>
+              <a:t>Persistent backend hosting for evaluation.</a:t>
             </a:r>
           </a:p>
           <a:p>
@@ -10472,7 +10511,7 @@
               </a:defRPr>
             </a:pPr>
             <a:r>
-              <a:t>Validate every required Google integration.</a:t>
+              <a:t>Cloud Run remains a deployment gap.</a:t>
             </a:r>
           </a:p>
           <a:p>
@@ -10501,7 +10540,7 @@
               </a:defRPr>
             </a:pPr>
             <a:r>
-              <a:t>Publish source and a working 3–4 minute demo.</a:t>
+              <a:t>Keep public source, video and deck accessible.</a:t>
             </a:r>
           </a:p>
         </p:txBody>
@@ -11331,7 +11370,7 @@
               </a:defRPr>
             </a:pPr>
             <a:r>
-              <a:t>GitHub Public Repository — publication pending</a:t>
+              <a:t>GitHub Public Repository</a:t>
             </a:r>
           </a:p>
         </p:txBody>
@@ -11459,7 +11498,7 @@
               </a:defRPr>
             </a:pPr>
             <a:r>
-              <a:t>Demo Video Link (3–4 minutes) — upload pending</a:t>
+              <a:t>Demo Video Link (3–4 minutes)</a:t>
             </a:r>
           </a:p>
         </p:txBody>
@@ -19428,7 +19467,7 @@
             </a:avLst>
           </a:prstGeom>
           <a:solidFill>
-            <a:srgbClr val="FFF4D9"/>
+            <a:srgbClr val="EBF7F0"/>
           </a:solidFill>
           <a:ln>
             <a:noFill/>
@@ -19484,13 +19523,13 @@
               </a:spcAft>
               <a:defRPr sz="950" b="1">
                 <a:solidFill>
-                  <a:srgbClr val="946000"/>
-                </a:solidFill>
-                <a:latin typeface="Aptos"/>
-              </a:defRPr>
-            </a:pPr>
-            <a:r>
-              <a:t>Firebase: pending</a:t>
+                  <a:srgbClr val="16845A"/>
+                </a:solidFill>
+                <a:latin typeface="Aptos"/>
+              </a:defRPr>
+            </a:pPr>
+            <a:r>
+              <a:t>Firebase: verified</a:t>
             </a:r>
           </a:p>
         </p:txBody>
@@ -19587,8 +19626,8 @@
         </p:nvSpPr>
         <p:spPr>
           <a:xfrm>
-            <a:off x="6135624" y="3172968"/>
-            <a:ext cx="2459736" cy="265176"/>
+            <a:off x="6035040" y="3118104"/>
+            <a:ext cx="2679192" cy="1060704"/>
           </a:xfrm>
           <a:prstGeom prst="roundRect">
             <a:avLst>
@@ -19596,10 +19635,12 @@
             </a:avLst>
           </a:prstGeom>
           <a:solidFill>
-            <a:srgbClr val="FFF4D9"/>
+            <a:srgbClr val="EBF7F0"/>
           </a:solidFill>
-          <a:ln>
-            <a:noFill/>
+          <a:ln w="10160">
+            <a:solidFill>
+              <a:srgbClr val="D8E1EE"/>
+            </a:solidFill>
           </a:ln>
         </p:spPr>
         <p:style>
@@ -19626,14 +19667,57 @@
       </p:sp>
       <p:sp>
         <p:nvSpPr>
-          <p:cNvPr id="137" name="TextBox 136"/>
-          <p:cNvSpPr txBox="1"/>
-          <p:nvPr/>
-        </p:nvSpPr>
-        <p:spPr>
-          <a:xfrm>
-            <a:off x="6208776" y="3204972"/>
-            <a:ext cx="2313432" cy="201168"/>
+          <p:cNvPr id="137" name="Rectangle 136"/>
+          <p:cNvSpPr/>
+          <p:nvPr/>
+        </p:nvSpPr>
+        <p:spPr>
+          <a:xfrm>
+            <a:off x="6035040" y="3118104"/>
+            <a:ext cx="41148" cy="1060704"/>
+          </a:xfrm>
+          <a:prstGeom prst="rect">
+            <a:avLst/>
+          </a:prstGeom>
+          <a:solidFill>
+            <a:srgbClr val="16845A"/>
+          </a:solidFill>
+          <a:ln>
+            <a:noFill/>
+          </a:ln>
+        </p:spPr>
+        <p:style>
+          <a:lnRef idx="1">
+            <a:schemeClr val="accent1"/>
+          </a:lnRef>
+          <a:fillRef idx="3">
+            <a:schemeClr val="accent1"/>
+          </a:fillRef>
+          <a:effectRef idx="2">
+            <a:schemeClr val="accent1"/>
+          </a:effectRef>
+          <a:fontRef idx="minor">
+            <a:schemeClr val="lt1"/>
+          </a:fontRef>
+        </p:style>
+        <p:txBody>
+          <a:bodyPr rtlCol="0" anchor="ctr"/>
+          <a:lstStyle/>
+          <a:p>
+            <a:pPr algn="ctr"/>
+          </a:p>
+        </p:txBody>
+      </p:sp>
+      <p:sp>
+        <p:nvSpPr>
+          <p:cNvPr id="138" name="TextBox 137"/>
+          <p:cNvSpPr txBox="1"/>
+          <p:nvPr/>
+        </p:nvSpPr>
+        <p:spPr>
+          <a:xfrm>
+            <a:off x="6181344" y="3246120"/>
+            <a:ext cx="2386584" cy="329184"/>
           </a:xfrm>
           <a:prstGeom prst="rect">
             <a:avLst/>
@@ -19650,29 +19734,29 @@
               <a:spcAft>
                 <a:spcPts val="300"/>
               </a:spcAft>
-              <a:defRPr sz="950" b="1">
-                <a:solidFill>
-                  <a:srgbClr val="946000"/>
-                </a:solidFill>
-                <a:latin typeface="Aptos"/>
-              </a:defRPr>
-            </a:pPr>
-            <a:r>
-              <a:t>Firestore: runtime pending</a:t>
-            </a:r>
-          </a:p>
-        </p:txBody>
-      </p:sp>
-      <p:sp>
-        <p:nvSpPr>
-          <p:cNvPr id="138" name="TextBox 137"/>
-          <p:cNvSpPr txBox="1"/>
-          <p:nvPr/>
-        </p:nvSpPr>
-        <p:spPr>
-          <a:xfrm>
-            <a:off x="6117336" y="3639312"/>
-            <a:ext cx="2560320" cy="713232"/>
+              <a:defRPr sz="1500" b="1">
+                <a:solidFill>
+                  <a:srgbClr val="16845A"/>
+                </a:solidFill>
+                <a:latin typeface="Aptos"/>
+              </a:defRPr>
+            </a:pPr>
+            <a:r>
+              <a:t>Firestore audit store</a:t>
+            </a:r>
+          </a:p>
+        </p:txBody>
+      </p:sp>
+      <p:sp>
+        <p:nvSpPr>
+          <p:cNvPr id="139" name="TextBox 138"/>
+          <p:cNvSpPr txBox="1"/>
+          <p:nvPr/>
+        </p:nvSpPr>
+        <p:spPr>
+          <a:xfrm>
+            <a:off x="6181344" y="3685032"/>
+            <a:ext cx="2386584" cy="420623"/>
           </a:xfrm>
           <a:prstGeom prst="rect">
             <a:avLst/>
@@ -19691,20 +19775,72 @@
               </a:spcAft>
               <a:defRPr sz="1200" b="0">
                 <a:solidFill>
-                  <a:srgbClr val="53637C"/>
-                </a:solidFill>
-                <a:latin typeface="Aptos"/>
-              </a:defRPr>
-            </a:pPr>
-            <a:r>
-              <a:t>Audit persistence is separate from the simulated business services.</a:t>
-            </a:r>
-          </a:p>
-        </p:txBody>
-      </p:sp>
-      <p:sp>
-        <p:nvSpPr>
-          <p:cNvPr id="139" name="TextBox 138"/>
+                  <a:srgbClr val="172336"/>
+                </a:solidFill>
+                <a:latin typeface="Aptos"/>
+              </a:defRPr>
+            </a:pPr>
+            <a:r>
+              <a:t>Saved report restored</a:t>
+            </a:r>
+          </a:p>
+          <a:p>
+            <a:pPr algn="l">
+              <a:spcAft>
+                <a:spcPts val="300"/>
+              </a:spcAft>
+              <a:defRPr sz="1200" b="0">
+                <a:solidFill>
+                  <a:srgbClr val="172336"/>
+                </a:solidFill>
+                <a:latin typeface="Aptos"/>
+              </a:defRPr>
+            </a:pPr>
+            <a:r>
+              <a:t>after server restart</a:t>
+            </a:r>
+          </a:p>
+        </p:txBody>
+      </p:sp>
+      <p:cxnSp>
+        <p:nvCxnSpPr>
+          <p:cNvPr id="140" name="Connector 139"/>
+          <p:cNvCxnSpPr/>
+          <p:nvPr/>
+        </p:nvCxnSpPr>
+        <p:spPr>
+          <a:xfrm>
+            <a:off x="5468112" y="2670048"/>
+            <a:ext cx="530352" cy="713232"/>
+          </a:xfrm>
+          <a:prstGeom prst="line">
+            <a:avLst/>
+          </a:prstGeom>
+          <a:ln w="19050">
+            <a:solidFill>
+              <a:srgbClr val="16845A"/>
+            </a:solidFill>
+            <a:tailEnd type="triangle"/>
+          </a:ln>
+        </p:spPr>
+        <p:style>
+          <a:lnRef idx="2">
+            <a:schemeClr val="accent1"/>
+          </a:lnRef>
+          <a:fillRef idx="0">
+            <a:schemeClr val="accent1"/>
+          </a:fillRef>
+          <a:effectRef idx="1">
+            <a:schemeClr val="accent1"/>
+          </a:effectRef>
+          <a:fontRef idx="minor">
+            <a:schemeClr val="tx1"/>
+          </a:fontRef>
+        </p:style>
+      </p:cxnSp>
+      <p:sp>
+        <p:nvSpPr>
+          <p:cNvPr id="141" name="TextBox 140"/>
           <p:cNvSpPr txBox="1"/>
           <p:nvPr/>
         </p:nvSpPr>
@@ -19743,7 +19879,7 @@
       </p:sp>
       <p:sp>
         <p:nvSpPr>
-          <p:cNvPr id="140" name="TextBox 139"/>
+          <p:cNvPr id="142" name="TextBox 141"/>
           <p:cNvSpPr txBox="1"/>
           <p:nvPr/>
         </p:nvSpPr>
@@ -20337,7 +20473,7 @@
             </a:avLst>
           </a:prstGeom>
           <a:solidFill>
-            <a:srgbClr val="FFF4D9"/>
+            <a:srgbClr val="EBF7F0"/>
           </a:solidFill>
           <a:ln>
             <a:noFill/>
@@ -20393,13 +20529,13 @@
               </a:spcAft>
               <a:defRPr sz="950" b="1">
                 <a:solidFill>
-                  <a:srgbClr val="946000"/>
-                </a:solidFill>
-                <a:latin typeface="Aptos"/>
-              </a:defRPr>
-            </a:pPr>
-            <a:r>
-              <a:t>Pending deployment</a:t>
+                  <a:srgbClr val="16845A"/>
+                </a:solidFill>
+                <a:latin typeface="Aptos"/>
+              </a:defRPr>
+            </a:pPr>
+            <a:r>
+              <a:t>Verified</a:t>
             </a:r>
           </a:p>
         </p:txBody>
@@ -20542,7 +20678,7 @@
             </a:avLst>
           </a:prstGeom>
           <a:solidFill>
-            <a:srgbClr val="FFF4D9"/>
+            <a:srgbClr val="EBF7F0"/>
           </a:solidFill>
           <a:ln>
             <a:noFill/>
@@ -20598,13 +20734,13 @@
               </a:spcAft>
               <a:defRPr sz="950" b="1">
                 <a:solidFill>
-                  <a:srgbClr val="946000"/>
-                </a:solidFill>
-                <a:latin typeface="Aptos"/>
-              </a:defRPr>
-            </a:pPr>
-            <a:r>
-              <a:t>Runtime check pending</a:t>
+                  <a:srgbClr val="16845A"/>
+                </a:solidFill>
+                <a:latin typeface="Aptos"/>
+              </a:defRPr>
+            </a:pPr>
+            <a:r>
+              <a:t>Verified</a:t>
             </a:r>
           </a:p>
         </p:txBody>

</xml_diff>